<commit_message>
Ajout commentaires + MaJ readme
</commit_message>
<xml_diff>
--- a/Documents/Diapo PizzaYolo.pptx
+++ b/Documents/Diapo PizzaYolo.pptx
@@ -19,6 +19,7 @@
     <p:sldId id="267" r:id="rId13"/>
     <p:sldId id="268" r:id="rId14"/>
     <p:sldId id="269" r:id="rId15"/>
+    <p:sldId id="270" r:id="rId16"/>
   </p:sldIdLst>
   <p:sldSz cx="12192000" cy="6858000"/>
   <p:notesSz cx="6858000" cy="9144000"/>
@@ -117,6 +118,11 @@
       </a:defRPr>
     </a:lvl9pPr>
   </p:defaultTextStyle>
+  <p:extLst>
+    <p:ext uri="{EFAFB233-063F-42B5-8137-9DF3F51BA10A}">
+      <p15:sldGuideLst xmlns:p15="http://schemas.microsoft.com/office/powerpoint/2012/main"/>
+    </p:ext>
+  </p:extLst>
 </p:presentation>
 </file>
 
@@ -267,7 +273,7 @@
           <a:p>
             <a:fld id="{87521E83-5C99-48EB-ADCE-C178C460669C}" type="datetimeFigureOut">
               <a:rPr lang="fr-FR" smtClean="0"/>
-              <a:t>31/03/2026</a:t>
+              <a:t>02/04/2026</a:t>
             </a:fld>
             <a:endParaRPr lang="fr-FR"/>
           </a:p>
@@ -465,7 +471,7 @@
           <a:p>
             <a:fld id="{87521E83-5C99-48EB-ADCE-C178C460669C}" type="datetimeFigureOut">
               <a:rPr lang="fr-FR" smtClean="0"/>
-              <a:t>31/03/2026</a:t>
+              <a:t>02/04/2026</a:t>
             </a:fld>
             <a:endParaRPr lang="fr-FR"/>
           </a:p>
@@ -673,7 +679,7 @@
           <a:p>
             <a:fld id="{87521E83-5C99-48EB-ADCE-C178C460669C}" type="datetimeFigureOut">
               <a:rPr lang="fr-FR" smtClean="0"/>
-              <a:t>31/03/2026</a:t>
+              <a:t>02/04/2026</a:t>
             </a:fld>
             <a:endParaRPr lang="fr-FR"/>
           </a:p>
@@ -871,7 +877,7 @@
           <a:p>
             <a:fld id="{87521E83-5C99-48EB-ADCE-C178C460669C}" type="datetimeFigureOut">
               <a:rPr lang="fr-FR" smtClean="0"/>
-              <a:t>31/03/2026</a:t>
+              <a:t>02/04/2026</a:t>
             </a:fld>
             <a:endParaRPr lang="fr-FR"/>
           </a:p>
@@ -1146,7 +1152,7 @@
           <a:p>
             <a:fld id="{87521E83-5C99-48EB-ADCE-C178C460669C}" type="datetimeFigureOut">
               <a:rPr lang="fr-FR" smtClean="0"/>
-              <a:t>31/03/2026</a:t>
+              <a:t>02/04/2026</a:t>
             </a:fld>
             <a:endParaRPr lang="fr-FR"/>
           </a:p>
@@ -1411,7 +1417,7 @@
           <a:p>
             <a:fld id="{87521E83-5C99-48EB-ADCE-C178C460669C}" type="datetimeFigureOut">
               <a:rPr lang="fr-FR" smtClean="0"/>
-              <a:t>31/03/2026</a:t>
+              <a:t>02/04/2026</a:t>
             </a:fld>
             <a:endParaRPr lang="fr-FR"/>
           </a:p>
@@ -1823,7 +1829,7 @@
           <a:p>
             <a:fld id="{87521E83-5C99-48EB-ADCE-C178C460669C}" type="datetimeFigureOut">
               <a:rPr lang="fr-FR" smtClean="0"/>
-              <a:t>31/03/2026</a:t>
+              <a:t>02/04/2026</a:t>
             </a:fld>
             <a:endParaRPr lang="fr-FR"/>
           </a:p>
@@ -1964,7 +1970,7 @@
           <a:p>
             <a:fld id="{87521E83-5C99-48EB-ADCE-C178C460669C}" type="datetimeFigureOut">
               <a:rPr lang="fr-FR" smtClean="0"/>
-              <a:t>31/03/2026</a:t>
+              <a:t>02/04/2026</a:t>
             </a:fld>
             <a:endParaRPr lang="fr-FR"/>
           </a:p>
@@ -2077,7 +2083,7 @@
           <a:p>
             <a:fld id="{87521E83-5C99-48EB-ADCE-C178C460669C}" type="datetimeFigureOut">
               <a:rPr lang="fr-FR" smtClean="0"/>
-              <a:t>31/03/2026</a:t>
+              <a:t>02/04/2026</a:t>
             </a:fld>
             <a:endParaRPr lang="fr-FR"/>
           </a:p>
@@ -2388,7 +2394,7 @@
           <a:p>
             <a:fld id="{87521E83-5C99-48EB-ADCE-C178C460669C}" type="datetimeFigureOut">
               <a:rPr lang="fr-FR" smtClean="0"/>
-              <a:t>31/03/2026</a:t>
+              <a:t>02/04/2026</a:t>
             </a:fld>
             <a:endParaRPr lang="fr-FR"/>
           </a:p>
@@ -2676,7 +2682,7 @@
           <a:p>
             <a:fld id="{87521E83-5C99-48EB-ADCE-C178C460669C}" type="datetimeFigureOut">
               <a:rPr lang="fr-FR" smtClean="0"/>
-              <a:t>31/03/2026</a:t>
+              <a:t>02/04/2026</a:t>
             </a:fld>
             <a:endParaRPr lang="fr-FR"/>
           </a:p>
@@ -2917,7 +2923,7 @@
           <a:p>
             <a:fld id="{87521E83-5C99-48EB-ADCE-C178C460669C}" type="datetimeFigureOut">
               <a:rPr lang="fr-FR" smtClean="0"/>
-              <a:t>31/03/2026</a:t>
+              <a:t>02/04/2026</a:t>
             </a:fld>
             <a:endParaRPr lang="fr-FR"/>
           </a:p>
@@ -4249,6 +4255,142 @@
     <p:extLst>
       <p:ext uri="{BB962C8B-B14F-4D97-AF65-F5344CB8AC3E}">
         <p14:creationId xmlns:p14="http://schemas.microsoft.com/office/powerpoint/2010/main" val="214664146"/>
+      </p:ext>
+    </p:extLst>
+  </p:cSld>
+  <p:clrMapOvr>
+    <a:masterClrMapping/>
+  </p:clrMapOvr>
+</p:sld>
+</file>
+
+<file path=ppt/slides/slide15.xml><?xml version="1.0" encoding="utf-8"?>
+<p:sld xmlns:a="http://schemas.openxmlformats.org/drawingml/2006/main" xmlns:r="http://schemas.openxmlformats.org/officeDocument/2006/relationships" xmlns:p="http://schemas.openxmlformats.org/presentationml/2006/main">
+  <p:cSld>
+    <p:spTree>
+      <p:nvGrpSpPr>
+        <p:cNvPr id="1" name=""/>
+        <p:cNvGrpSpPr/>
+        <p:nvPr/>
+      </p:nvGrpSpPr>
+      <p:grpSpPr>
+        <a:xfrm>
+          <a:off x="0" y="0"/>
+          <a:ext cx="0" cy="0"/>
+          <a:chOff x="0" y="0"/>
+          <a:chExt cx="0" cy="0"/>
+        </a:xfrm>
+      </p:grpSpPr>
+      <p:sp>
+        <p:nvSpPr>
+          <p:cNvPr id="2" name="Titre 1">
+            <a:extLst>
+              <a:ext uri="{FF2B5EF4-FFF2-40B4-BE49-F238E27FC236}">
+                <a16:creationId xmlns:a16="http://schemas.microsoft.com/office/drawing/2014/main" id="{18FE942A-F79F-49AD-61A5-A90B62F970C1}"/>
+              </a:ext>
+            </a:extLst>
+          </p:cNvPr>
+          <p:cNvSpPr>
+            <a:spLocks noGrp="1"/>
+          </p:cNvSpPr>
+          <p:nvPr>
+            <p:ph type="title"/>
+          </p:nvPr>
+        </p:nvSpPr>
+        <p:spPr/>
+        <p:txBody>
+          <a:bodyPr/>
+          <a:lstStyle/>
+          <a:p>
+            <a:r>
+              <a:rPr lang="fr-FR" dirty="0"/>
+              <a:t>Test Unitaire</a:t>
+            </a:r>
+          </a:p>
+        </p:txBody>
+      </p:sp>
+      <p:sp>
+        <p:nvSpPr>
+          <p:cNvPr id="3" name="Espace réservé du contenu 2">
+            <a:extLst>
+              <a:ext uri="{FF2B5EF4-FFF2-40B4-BE49-F238E27FC236}">
+                <a16:creationId xmlns:a16="http://schemas.microsoft.com/office/drawing/2014/main" id="{21579BB1-5915-5986-74D0-3924742E822C}"/>
+              </a:ext>
+            </a:extLst>
+          </p:cNvPr>
+          <p:cNvSpPr>
+            <a:spLocks noGrp="1"/>
+          </p:cNvSpPr>
+          <p:nvPr>
+            <p:ph idx="1"/>
+          </p:nvPr>
+        </p:nvSpPr>
+        <p:spPr/>
+        <p:txBody>
+          <a:bodyPr/>
+          <a:lstStyle/>
+          <a:p>
+            <a:r>
+              <a:rPr lang="fr-FR" dirty="0"/>
+              <a:t>Mise en place de tests unitaires avec </a:t>
+            </a:r>
+            <a:r>
+              <a:rPr lang="fr-FR" dirty="0" err="1"/>
+              <a:t>PHPUnit</a:t>
+            </a:r>
+            <a:r>
+              <a:rPr lang="fr-FR" dirty="0"/>
+              <a:t> </a:t>
+            </a:r>
+          </a:p>
+          <a:p>
+            <a:pPr marL="0" indent="0">
+              <a:buNone/>
+            </a:pPr>
+            <a:endParaRPr lang="fr-FR" dirty="0"/>
+          </a:p>
+        </p:txBody>
+      </p:sp>
+      <p:pic>
+        <p:nvPicPr>
+          <p:cNvPr id="5" name="Image 4">
+            <a:extLst>
+              <a:ext uri="{FF2B5EF4-FFF2-40B4-BE49-F238E27FC236}">
+                <a16:creationId xmlns:a16="http://schemas.microsoft.com/office/drawing/2014/main" id="{FE268C08-67C6-9423-3D0C-033BA74E513C}"/>
+              </a:ext>
+            </a:extLst>
+          </p:cNvPr>
+          <p:cNvPicPr>
+            <a:picLocks noChangeAspect="1"/>
+          </p:cNvPicPr>
+          <p:nvPr/>
+        </p:nvPicPr>
+        <p:blipFill>
+          <a:blip r:embed="rId2">
+            <a:extLst>
+              <a:ext uri="{28A0092B-C50C-407E-A947-70E740481C1C}">
+                <a14:useLocalDpi xmlns:a14="http://schemas.microsoft.com/office/drawing/2010/main" val="0"/>
+              </a:ext>
+            </a:extLst>
+          </a:blip>
+          <a:stretch>
+            <a:fillRect/>
+          </a:stretch>
+        </p:blipFill>
+        <p:spPr>
+          <a:xfrm>
+            <a:off x="838200" y="2450221"/>
+            <a:ext cx="8031480" cy="2156045"/>
+          </a:xfrm>
+          <a:prstGeom prst="rect">
+            <a:avLst/>
+          </a:prstGeom>
+        </p:spPr>
+      </p:pic>
+    </p:spTree>
+    <p:extLst>
+      <p:ext uri="{BB962C8B-B14F-4D97-AF65-F5344CB8AC3E}">
+        <p14:creationId xmlns:p14="http://schemas.microsoft.com/office/powerpoint/2010/main" val="2331706399"/>
       </p:ext>
     </p:extLst>
   </p:cSld>

</xml_diff>